<commit_message>
PulseQoS v2: corrected design document, AI layer and updated slide
Fix second-pass gaps (overhead compensation, ACK filter, GSO, CAKE
autorate-ingress baseline, inconclusive trials, VPN limit, expected-output
mapping) and add the conformal classifier, Experience Twin and Zero-click
Focus, each with a deterministic baseline.

Co-Authored-By: Claude Opus 5.5 <noreply@anthropic.com>
Claude-Session: https://claude.ai/code/session_01KSZ4mJfYWy31b5hWc3yBC3
</commit_message>
<xml_diff>
--- a/pulseqos/slides/PulseQoS_TELIPORT_S4_CaseStudy3.pptx
+++ b/pulseqos/slides/PulseQoS_TELIPORT_S4_CaseStudy3.pptx
@@ -125,7 +125,7 @@
           <a:lstStyle/>
           <a:p>
             <a:r>
-              <a:rPr sz="950" b="1">
+              <a:rPr sz="900" b="1">
                 <a:solidFill>
                   <a:srgbClr val="0B2E4F"/>
                 </a:solidFill>
@@ -182,7 +182,7 @@
                   <c:v>FIFO (no QoS)</c:v>
                 </c:pt>
                 <c:pt idx="1">
-                  <c:v>Class shaping (HTB layout)</c:v>
+                  <c:v>Class shaping (HTB)</c:v>
                 </c:pt>
               </c:strCache>
             </c:strRef>
@@ -223,7 +223,7 @@
           <c:showBubbleSize val="0"/>
           <c:showLeaderLines val="1"/>
         </c:dLbls>
-        <c:gapWidth val="60"/>
+        <c:gapWidth val="50"/>
         <c:axId val="-2068027336"/>
         <c:axId val="-2113994440"/>
       </c:barChart>
@@ -685,7 +685,7 @@
           <a:lstStyle/>
           <a:p>
             <a:r>
-              <a:t>60-second pitch: Home links carry calls, games, TVs and downloads at once. Big queues, not low bandwidth, ruin calls. PulseQoS sits on proven Linux CAKE and adds four things: it understands traffic from metadata only and admits uncertainty; it follows the real link speed within a second; it takes a temporary user intent with expiry and a fairness budget; and it verifies every policy change, rolling back if the call gets worse. Our pilot already shows the problem and the fix: a download pushed call-probe p95 delay to 138 ms on FIFO and kept it under 0.1 ms with class shaping, with identical download goodput. Round 2 measures PulseQoS against CAKE and CAKE-autorate, not just against no QoS.</a:t>
+              <a:t>60-second pitch: Home links carry calls, games, TVs and downloads at once; big queues, not low bandwidth, ruin calls. PulseQoS runs on proven Linux CAKE with a fast loop that follows the real link speed within a second, and a slow, safety-gated loop for policy. Our AI layer is what nobody else has, and each part must beat a rule-based twin: a conformal classifier that only boosts traffic when it is certain, so wrong boosts stay under a chosen rate; an Experience Twin, a learned model of the home link that predicts the effect of every change and rejects harmful ones before users feel them; and Zero-click Focus, which protects a call the moment it starts, with a fairness budget and undo. Our pilot already shows the problem and the fix: a download pushed call delay to 138 ms on FIFO; class shaping kept it under 0.1 ms with the same download speed. In Round 2 we measure against CAKE and its autorate, not just against no QoS.</a:t>
             </a:r>
           </a:p>
         </p:txBody>
@@ -7560,7 +7560,7 @@
                 </a:solidFill>
                 <a:latin typeface="Calibri"/>
               </a:rPr>
-              <a:t>“protect my call for 30 min” • authenticated, rate-limited</a:t>
+              <a:t>manual intent or Zero-click auto-protect • 1-tap undo</a:t>
             </a:r>
           </a:p>
         </p:txBody>
@@ -7629,7 +7629,7 @@
                 </a:solidFill>
                 <a:latin typeface="Calibri"/>
               </a:rPr>
-              <a:t>p95 delay, jitter, loss, queue, Jain • audit timeline</a:t>
+              <a:t>p95, jitter, loss, queue, Jain, RPM • Twin prediction vs real</a:t>
             </a:r>
           </a:p>
         </p:txBody>
@@ -7643,7 +7643,7 @@
         <p:spPr>
           <a:xfrm>
             <a:off x="1170432" y="1737360"/>
-            <a:ext cx="1874519" cy="1097280"/>
+            <a:ext cx="1417320" cy="1097280"/>
           </a:xfrm>
           <a:prstGeom prst="roundRect">
             <a:avLst>
@@ -7678,61 +7678,61 @@
           <a:p>
             <a:pPr algn="ctr"/>
             <a:r>
-              <a:rPr sz="950" b="1">
+              <a:rPr sz="900" b="1">
                 <a:solidFill>
                   <a:srgbClr val="F5B400"/>
                 </a:solidFill>
                 <a:latin typeface="Calibri"/>
               </a:rPr>
-              <a:t>FAST LOOP (≤ 1 s)</a:t>
+              <a:t>FAST LOOP ≤ 1 s</a:t>
             </a:r>
           </a:p>
           <a:p>
             <a:pPr algn="ctr"/>
             <a:r>
-              <a:rPr sz="850" b="0">
+              <a:rPr sz="800" b="0">
                 <a:solidFill>
                   <a:srgbClr val="FFFFFF"/>
                 </a:solidFill>
                 <a:latin typeface="Calibri"/>
               </a:rPr>
-              <a:t>Capacity estimator</a:t>
+              <a:t>capacity estimator</a:t>
             </a:r>
           </a:p>
           <a:p>
             <a:pPr algn="ctr"/>
             <a:r>
-              <a:rPr sz="850" b="0">
+              <a:rPr sz="800" b="0">
                 <a:solidFill>
                   <a:srgbClr val="FFFFFF"/>
                 </a:solidFill>
                 <a:latin typeface="Calibri"/>
               </a:rPr>
-              <a:t>OWD / RTT under load</a:t>
+              <a:t>one-way delay</a:t>
             </a:r>
           </a:p>
           <a:p>
             <a:pPr algn="ctr"/>
             <a:r>
-              <a:rPr sz="850" b="0">
+              <a:rPr sz="800" b="0">
                 <a:solidFill>
                   <a:srgbClr val="FFFFFF"/>
                 </a:solidFill>
                 <a:latin typeface="Calibri"/>
               </a:rPr>
-              <a:t>AIMD shaper rate</a:t>
+              <a:t>rate cuts act at</a:t>
             </a:r>
           </a:p>
           <a:p>
             <a:pPr algn="ctr"/>
             <a:r>
-              <a:rPr sz="850" b="0">
+              <a:rPr sz="800" b="0">
                 <a:solidFill>
                   <a:srgbClr val="FFFFFF"/>
                 </a:solidFill>
                 <a:latin typeface="Calibri"/>
               </a:rPr>
-              <a:t>(rate cuts skip trial)</a:t>
+              <a:t>once, skip trial</a:t>
             </a:r>
           </a:p>
         </p:txBody>
@@ -7745,8 +7745,8 @@
         </p:nvSpPr>
         <p:spPr>
           <a:xfrm>
-            <a:off x="3136391" y="1737360"/>
-            <a:ext cx="1965960" cy="1097280"/>
+            <a:off x="2670048" y="1737360"/>
+            <a:ext cx="1417320" cy="1097280"/>
           </a:xfrm>
           <a:prstGeom prst="roundRect">
             <a:avLst>
@@ -7781,61 +7781,61 @@
           <a:p>
             <a:pPr algn="ctr"/>
             <a:r>
-              <a:rPr sz="950" b="1">
+              <a:rPr sz="900" b="1">
                 <a:solidFill>
                   <a:srgbClr val="F5B400"/>
                 </a:solidFill>
                 <a:latin typeface="Calibri"/>
               </a:rPr>
-              <a:t>SLOW LOOP (10–30 s)</a:t>
+              <a:t>SLOW LOOP 10–30 s</a:t>
             </a:r>
           </a:p>
           <a:p>
             <a:pPr algn="ctr"/>
             <a:r>
-              <a:rPr sz="850" b="0">
+              <a:rPr sz="800" b="0">
                 <a:solidFill>
                   <a:srgbClr val="FFFFFF"/>
                 </a:solidFill>
                 <a:latin typeface="Calibri"/>
               </a:rPr>
-              <a:t>Policy controller</a:t>
+              <a:t>policy controller</a:t>
             </a:r>
           </a:p>
           <a:p>
             <a:pPr algn="ctr"/>
             <a:r>
-              <a:rPr sz="850" b="0">
+              <a:rPr sz="800" b="0">
                 <a:solidFill>
                   <a:srgbClr val="FFFFFF"/>
                 </a:solidFill>
                 <a:latin typeface="Calibri"/>
               </a:rPr>
-              <a:t>deterministic rules +</a:t>
+              <a:t>safe action menu</a:t>
             </a:r>
           </a:p>
           <a:p>
             <a:pPr algn="ctr"/>
             <a:r>
-              <a:rPr sz="850" b="0">
+              <a:rPr sz="800" b="0">
                 <a:solidFill>
                   <a:srgbClr val="FFFFFF"/>
                 </a:solidFill>
                 <a:latin typeface="Calibri"/>
               </a:rPr>
-              <a:t>safe action menu,</a:t>
+              <a:t>hysteresis +</a:t>
             </a:r>
           </a:p>
           <a:p>
             <a:pPr algn="ctr"/>
             <a:r>
-              <a:rPr sz="850" b="0">
+              <a:rPr sz="800" b="0">
                 <a:solidFill>
                   <a:srgbClr val="FFFFFF"/>
                 </a:solidFill>
                 <a:latin typeface="Calibri"/>
               </a:rPr>
-              <a:t>hysteresis, hold time</a:t>
+              <a:t>hold time</a:t>
             </a:r>
           </a:p>
         </p:txBody>
@@ -7848,8 +7848,111 @@
         </p:nvSpPr>
         <p:spPr>
           <a:xfrm>
-            <a:off x="5193792" y="1737360"/>
-            <a:ext cx="1892807" cy="1097280"/>
+            <a:off x="4169663" y="1737360"/>
+            <a:ext cx="1417320" cy="1097280"/>
+          </a:xfrm>
+          <a:prstGeom prst="roundRect">
+            <a:avLst>
+              <a:gd name="adj" fmla="val 8000"/>
+            </a:avLst>
+          </a:prstGeom>
+          <a:solidFill>
+            <a:srgbClr val="7A3FC9"/>
+          </a:solidFill>
+          <a:ln>
+            <a:noFill/>
+          </a:ln>
+          <a:effectLst/>
+        </p:spPr>
+        <p:style>
+          <a:lnRef idx="1">
+            <a:schemeClr val="accent1"/>
+          </a:lnRef>
+          <a:fillRef idx="3">
+            <a:schemeClr val="accent1"/>
+          </a:fillRef>
+          <a:effectRef idx="2">
+            <a:schemeClr val="accent1"/>
+          </a:effectRef>
+          <a:fontRef idx="minor">
+            <a:schemeClr val="lt1"/>
+          </a:fontRef>
+        </p:style>
+        <p:txBody>
+          <a:bodyPr rtlCol="0" anchor="ctr" wrap="square" lIns="54864" rIns="54864" tIns="27432" bIns="27432"/>
+          <a:lstStyle/>
+          <a:p>
+            <a:pPr algn="ctr"/>
+            <a:r>
+              <a:rPr sz="900" b="1">
+                <a:solidFill>
+                  <a:srgbClr val="FFFFFF"/>
+                </a:solidFill>
+                <a:latin typeface="Calibri"/>
+              </a:rPr>
+              <a:t>AI  Experience Twin</a:t>
+            </a:r>
+          </a:p>
+          <a:p>
+            <a:pPr algn="ctr"/>
+            <a:r>
+              <a:rPr sz="800" b="0">
+                <a:solidFill>
+                  <a:srgbClr val="FFFFFF"/>
+                </a:solidFill>
+                <a:latin typeface="Calibri"/>
+              </a:rPr>
+              <a:t>predicts next-10 s</a:t>
+            </a:r>
+          </a:p>
+          <a:p>
+            <a:pPr algn="ctr"/>
+            <a:r>
+              <a:rPr sz="800" b="0">
+                <a:solidFill>
+                  <a:srgbClr val="FFFFFF"/>
+                </a:solidFill>
+                <a:latin typeface="Calibri"/>
+              </a:rPr>
+              <a:t>call delay for each</a:t>
+            </a:r>
+          </a:p>
+          <a:p>
+            <a:pPr algn="ctr"/>
+            <a:r>
+              <a:rPr sz="800" b="0">
+                <a:solidFill>
+                  <a:srgbClr val="FFFFFF"/>
+                </a:solidFill>
+                <a:latin typeface="Calibri"/>
+              </a:rPr>
+              <a:t>action; drops unsafe</a:t>
+            </a:r>
+          </a:p>
+          <a:p>
+            <a:pPr algn="ctr"/>
+            <a:r>
+              <a:rPr sz="800" b="0">
+                <a:solidFill>
+                  <a:srgbClr val="FFFFFF"/>
+                </a:solidFill>
+                <a:latin typeface="Calibri"/>
+              </a:rPr>
+              <a:t>ones before users feel</a:t>
+            </a:r>
+          </a:p>
+        </p:txBody>
+      </p:sp>
+      <p:sp>
+        <p:nvSpPr>
+          <p:cNvPr id="24" name="Rounded Rectangle 23"/>
+          <p:cNvSpPr/>
+          <p:nvPr/>
+        </p:nvSpPr>
+        <p:spPr>
+          <a:xfrm>
+            <a:off x="5669280" y="1737360"/>
+            <a:ext cx="1417320" cy="1097280"/>
           </a:xfrm>
           <a:prstGeom prst="roundRect">
             <a:avLst>
@@ -7886,7 +7989,7 @@
           <a:p>
             <a:pPr algn="ctr"/>
             <a:r>
-              <a:rPr sz="950" b="1">
+              <a:rPr sz="900" b="1">
                 <a:solidFill>
                   <a:srgbClr val="0B2E4F"/>
                 </a:solidFill>
@@ -7898,56 +8001,56 @@
           <a:p>
             <a:pPr algn="ctr"/>
             <a:r>
-              <a:rPr sz="850" b="0">
+              <a:rPr sz="800" b="0">
                 <a:solidFill>
                   <a:srgbClr val="333333"/>
                 </a:solidFill>
                 <a:latin typeface="Calibri"/>
               </a:rPr>
-              <a:t>validate → bounded</a:t>
+              <a:t>validate → live</a:t>
             </a:r>
           </a:p>
           <a:p>
             <a:pPr algn="ctr"/>
             <a:r>
-              <a:rPr sz="850" b="0">
+              <a:rPr sz="800" b="0">
                 <a:solidFill>
                   <a:srgbClr val="333333"/>
                 </a:solidFill>
                 <a:latin typeface="Calibri"/>
               </a:rPr>
-              <a:t>live trial → keep or</a:t>
+              <a:t>trial → keep or</a:t>
             </a:r>
           </a:p>
           <a:p>
             <a:pPr algn="ctr"/>
             <a:r>
-              <a:rPr sz="850" b="0">
+              <a:rPr sz="800" b="0">
                 <a:solidFill>
                   <a:srgbClr val="333333"/>
                 </a:solidFill>
                 <a:latin typeface="Calibri"/>
               </a:rPr>
-              <a:t>roll back whole bundle</a:t>
+              <a:t>roll back • watchdog</a:t>
             </a:r>
           </a:p>
           <a:p>
             <a:pPr algn="ctr"/>
             <a:r>
-              <a:rPr sz="850" b="0">
+              <a:rPr sz="800" b="0">
                 <a:solidFill>
                   <a:srgbClr val="333333"/>
                 </a:solidFill>
                 <a:latin typeface="Calibri"/>
               </a:rPr>
-              <a:t>+ watchdog → safe state</a:t>
-            </a:r>
-          </a:p>
-        </p:txBody>
-      </p:sp>
-      <p:sp>
-        <p:nvSpPr>
-          <p:cNvPr id="24" name="Rounded Rectangle 23"/>
+              <a:t>→ safe state</a:t>
+            </a:r>
+          </a:p>
+        </p:txBody>
+      </p:sp>
+      <p:sp>
+        <p:nvSpPr>
+          <p:cNvPr id="25" name="Rounded Rectangle 24"/>
           <p:cNvSpPr/>
           <p:nvPr/>
         </p:nvSpPr>
@@ -7997,7 +8100,7 @@
                 </a:solidFill>
                 <a:latin typeface="Calibri"/>
               </a:rPr>
-              <a:t>Flow table (conntrack) • telemetry store • versioned policy bundles • audit log</a:t>
+              <a:t>Flow table (conntrack) • telemetry • versioned policy bundles • audit log • Twin training set</a:t>
             </a:r>
           </a:p>
           <a:p>
@@ -8016,7 +8119,7 @@
       </p:sp>
       <p:sp>
         <p:nvSpPr>
-          <p:cNvPr id="25" name="Rounded Rectangle 24"/>
+          <p:cNvPr id="26" name="Rounded Rectangle 25"/>
           <p:cNvSpPr/>
           <p:nvPr/>
         </p:nvSpPr>
@@ -8031,12 +8134,10 @@
             </a:avLst>
           </a:prstGeom>
           <a:solidFill>
-            <a:srgbClr val="FFFFFF"/>
+            <a:srgbClr val="7A3FC9"/>
           </a:solidFill>
-          <a:ln w="12700">
-            <a:solidFill>
-              <a:srgbClr val="008CC8"/>
-            </a:solidFill>
+          <a:ln>
+            <a:noFill/>
           </a:ln>
           <a:effectLst/>
         </p:spPr>
@@ -8062,11 +8163,11 @@
             <a:r>
               <a:rPr sz="950" b="1">
                 <a:solidFill>
-                  <a:srgbClr val="0B2E4F"/>
+                  <a:srgbClr val="FFFFFF"/>
                 </a:solidFill>
                 <a:latin typeface="Calibri"/>
               </a:rPr>
-              <a:t>Flow classifier</a:t>
+              <a:t>AI  Conformal classifier</a:t>
             </a:r>
           </a:p>
           <a:p>
@@ -8074,11 +8175,11 @@
             <a:r>
               <a:rPr sz="850" b="0">
                 <a:solidFill>
-                  <a:srgbClr val="333333"/>
+                  <a:srgbClr val="FFFFFF"/>
                 </a:solidFill>
                 <a:latin typeface="Calibri"/>
               </a:rPr>
-              <a:t>sizes, timing, direction</a:t>
+              <a:t>metadata only • boosts only</a:t>
             </a:r>
           </a:p>
           <a:p>
@@ -8086,18 +8187,18 @@
             <a:r>
               <a:rPr sz="850" b="0">
                 <a:solidFill>
-                  <a:srgbClr val="333333"/>
+                  <a:srgbClr val="FFFFFF"/>
                 </a:solidFill>
                 <a:latin typeface="Calibri"/>
               </a:rPr>
-              <a:t>calibrated conf. + Unknown</a:t>
-            </a:r>
-          </a:p>
-        </p:txBody>
-      </p:sp>
-      <p:sp>
-        <p:nvSpPr>
-          <p:cNvPr id="26" name="Rounded Rectangle 25"/>
+              <a:t>when certain, else Unknown</a:t>
+            </a:r>
+          </a:p>
+        </p:txBody>
+      </p:sp>
+      <p:sp>
+        <p:nvSpPr>
+          <p:cNvPr id="27" name="Rounded Rectangle 26"/>
           <p:cNvSpPr/>
           <p:nvPr/>
         </p:nvSpPr>
@@ -8147,7 +8248,7 @@
                 </a:solidFill>
                 <a:latin typeface="Calibri"/>
               </a:rPr>
-              <a:t>Mark per flow</a:t>
+              <a:t>One mark per flow</a:t>
             </a:r>
           </a:p>
           <a:p>
@@ -8171,14 +8272,14 @@
                 </a:solidFill>
                 <a:latin typeface="Calibri"/>
               </a:rPr>
-              <a:t>(user correction wins)</a:t>
-            </a:r>
-          </a:p>
-        </p:txBody>
-      </p:sp>
-      <p:sp>
-        <p:nvSpPr>
-          <p:cNvPr id="27" name="Rounded Rectangle 26"/>
+              <a:t>restored both ways (ctinfo)</a:t>
+            </a:r>
+          </a:p>
+        </p:txBody>
+      </p:sp>
+      <p:sp>
+        <p:nvSpPr>
+          <p:cNvPr id="28" name="Rounded Rectangle 27"/>
           <p:cNvSpPr/>
           <p:nvPr/>
         </p:nvSpPr>
@@ -8252,14 +8353,14 @@
                 </a:solidFill>
                 <a:latin typeface="Calibri"/>
               </a:rPr>
-              <a:t>(ctinfo restore) • HTB variant</a:t>
-            </a:r>
-          </a:p>
-        </p:txBody>
-      </p:sp>
-      <p:sp>
-        <p:nvSpPr>
-          <p:cNvPr id="28" name="Rounded Rectangle 27"/>
+              <a:t>HTB variant for floors</a:t>
+            </a:r>
+          </a:p>
+        </p:txBody>
+      </p:sp>
+      <p:sp>
+        <p:nvSpPr>
+          <p:cNvPr id="29" name="Rounded Rectangle 28"/>
           <p:cNvSpPr/>
           <p:nvPr/>
         </p:nvSpPr>
@@ -8321,14 +8422,14 @@
                 </a:solidFill>
                 <a:latin typeface="Calibri"/>
               </a:rPr>
-              <a:t>laptop call • console • 3 TVs • 15 GB download</a:t>
-            </a:r>
-          </a:p>
-        </p:txBody>
-      </p:sp>
-      <p:sp>
-        <p:nvSpPr>
-          <p:cNvPr id="29" name="Rounded Rectangle 28"/>
+              <a:t>laptop calls • console • 3 TVs • 15 GB download</a:t>
+            </a:r>
+          </a:p>
+        </p:txBody>
+      </p:sp>
+      <p:sp>
+        <p:nvSpPr>
+          <p:cNvPr id="30" name="Rounded Rectangle 29"/>
           <p:cNvSpPr/>
           <p:nvPr/>
         </p:nvSpPr>
@@ -8397,7 +8498,7 @@
       </p:sp>
       <p:cxnSp>
         <p:nvCxnSpPr>
-          <p:cNvPr id="30" name="Connector 29"/>
+          <p:cNvPr id="31" name="Connector 30"/>
           <p:cNvCxnSpPr/>
           <p:nvPr/>
         </p:nvCxnSpPr>
@@ -8433,7 +8534,7 @@
       </p:cxnSp>
       <p:cxnSp>
         <p:nvCxnSpPr>
-          <p:cNvPr id="31" name="Connector 30"/>
+          <p:cNvPr id="32" name="Connector 31"/>
           <p:cNvCxnSpPr/>
           <p:nvPr/>
         </p:nvCxnSpPr>
@@ -8469,7 +8570,7 @@
       </p:cxnSp>
       <p:cxnSp>
         <p:nvCxnSpPr>
-          <p:cNvPr id="32" name="Connector 31"/>
+          <p:cNvPr id="33" name="Connector 32"/>
           <p:cNvCxnSpPr/>
           <p:nvPr/>
         </p:nvCxnSpPr>
@@ -8505,7 +8606,7 @@
       </p:cxnSp>
       <p:cxnSp>
         <p:nvCxnSpPr>
-          <p:cNvPr id="33" name="Connector 32"/>
+          <p:cNvPr id="34" name="Connector 33"/>
           <p:cNvCxnSpPr/>
           <p:nvPr/>
         </p:nvCxnSpPr>
@@ -8541,13 +8642,121 @@
       </p:cxnSp>
       <p:cxnSp>
         <p:nvCxnSpPr>
-          <p:cNvPr id="34" name="Connector 33"/>
+          <p:cNvPr id="35" name="Connector 34"/>
           <p:cNvCxnSpPr/>
           <p:nvPr/>
         </p:nvCxnSpPr>
         <p:spPr>
           <a:xfrm>
-            <a:off x="4114800" y="2834640"/>
+            <a:off x="4087368" y="2286000"/>
+            <a:ext cx="82295" cy="0"/>
+          </a:xfrm>
+          <a:prstGeom prst="line">
+            <a:avLst/>
+          </a:prstGeom>
+          <a:ln w="19050">
+            <a:solidFill>
+              <a:srgbClr val="0B2E4F"/>
+            </a:solidFill>
+            <a:tailEnd type="triangle"/>
+          </a:ln>
+        </p:spPr>
+        <p:style>
+          <a:lnRef idx="2">
+            <a:schemeClr val="accent1"/>
+          </a:lnRef>
+          <a:fillRef idx="0">
+            <a:schemeClr val="accent1"/>
+          </a:fillRef>
+          <a:effectRef idx="1">
+            <a:schemeClr val="accent1"/>
+          </a:effectRef>
+          <a:fontRef idx="minor">
+            <a:schemeClr val="tx1"/>
+          </a:fontRef>
+        </p:style>
+      </p:cxnSp>
+      <p:cxnSp>
+        <p:nvCxnSpPr>
+          <p:cNvPr id="36" name="Connector 35"/>
+          <p:cNvCxnSpPr/>
+          <p:nvPr/>
+        </p:nvCxnSpPr>
+        <p:spPr>
+          <a:xfrm>
+            <a:off x="5586984" y="2286000"/>
+            <a:ext cx="82296" cy="0"/>
+          </a:xfrm>
+          <a:prstGeom prst="line">
+            <a:avLst/>
+          </a:prstGeom>
+          <a:ln w="19050">
+            <a:solidFill>
+              <a:srgbClr val="0B2E4F"/>
+            </a:solidFill>
+            <a:tailEnd type="triangle"/>
+          </a:ln>
+        </p:spPr>
+        <p:style>
+          <a:lnRef idx="2">
+            <a:schemeClr val="accent1"/>
+          </a:lnRef>
+          <a:fillRef idx="0">
+            <a:schemeClr val="accent1"/>
+          </a:fillRef>
+          <a:effectRef idx="1">
+            <a:schemeClr val="accent1"/>
+          </a:effectRef>
+          <a:fontRef idx="minor">
+            <a:schemeClr val="tx1"/>
+          </a:fontRef>
+        </p:style>
+      </p:cxnSp>
+      <p:cxnSp>
+        <p:nvCxnSpPr>
+          <p:cNvPr id="37" name="Connector 36"/>
+          <p:cNvCxnSpPr/>
+          <p:nvPr/>
+        </p:nvCxnSpPr>
+        <p:spPr>
+          <a:xfrm>
+            <a:off x="6931152" y="2834640"/>
+            <a:ext cx="0" cy="676656"/>
+          </a:xfrm>
+          <a:prstGeom prst="line">
+            <a:avLst/>
+          </a:prstGeom>
+          <a:ln w="19050">
+            <a:solidFill>
+              <a:srgbClr val="0B2E4F"/>
+            </a:solidFill>
+            <a:tailEnd type="triangle"/>
+          </a:ln>
+        </p:spPr>
+        <p:style>
+          <a:lnRef idx="2">
+            <a:schemeClr val="accent1"/>
+          </a:lnRef>
+          <a:fillRef idx="0">
+            <a:schemeClr val="accent1"/>
+          </a:fillRef>
+          <a:effectRef idx="1">
+            <a:schemeClr val="accent1"/>
+          </a:effectRef>
+          <a:fontRef idx="minor">
+            <a:schemeClr val="tx1"/>
+          </a:fontRef>
+        </p:style>
+      </p:cxnSp>
+      <p:cxnSp>
+        <p:nvCxnSpPr>
+          <p:cNvPr id="38" name="Connector 37"/>
+          <p:cNvCxnSpPr/>
+          <p:nvPr/>
+        </p:nvCxnSpPr>
+        <p:spPr>
+          <a:xfrm>
+            <a:off x="1883664" y="2834640"/>
             <a:ext cx="0" cy="137160"/>
           </a:xfrm>
           <a:prstGeom prst="line">
@@ -8577,79 +8786,7 @@
       </p:cxnSp>
       <p:cxnSp>
         <p:nvCxnSpPr>
-          <p:cNvPr id="35" name="Connector 34"/>
-          <p:cNvCxnSpPr/>
-          <p:nvPr/>
-        </p:nvCxnSpPr>
-        <p:spPr>
-          <a:xfrm>
-            <a:off x="5102352" y="2286000"/>
-            <a:ext cx="91440" cy="0"/>
-          </a:xfrm>
-          <a:prstGeom prst="line">
-            <a:avLst/>
-          </a:prstGeom>
-          <a:ln w="19050">
-            <a:solidFill>
-              <a:srgbClr val="0B2E4F"/>
-            </a:solidFill>
-            <a:tailEnd type="triangle"/>
-          </a:ln>
-        </p:spPr>
-        <p:style>
-          <a:lnRef idx="2">
-            <a:schemeClr val="accent1"/>
-          </a:lnRef>
-          <a:fillRef idx="0">
-            <a:schemeClr val="accent1"/>
-          </a:fillRef>
-          <a:effectRef idx="1">
-            <a:schemeClr val="accent1"/>
-          </a:effectRef>
-          <a:fontRef idx="minor">
-            <a:schemeClr val="tx1"/>
-          </a:fontRef>
-        </p:style>
-      </p:cxnSp>
-      <p:cxnSp>
-        <p:nvCxnSpPr>
-          <p:cNvPr id="36" name="Connector 35"/>
-          <p:cNvCxnSpPr/>
-          <p:nvPr/>
-        </p:nvCxnSpPr>
-        <p:spPr>
-          <a:xfrm>
-            <a:off x="6135624" y="2834640"/>
-            <a:ext cx="0" cy="676656"/>
-          </a:xfrm>
-          <a:prstGeom prst="line">
-            <a:avLst/>
-          </a:prstGeom>
-          <a:ln w="19050">
-            <a:solidFill>
-              <a:srgbClr val="0B2E4F"/>
-            </a:solidFill>
-            <a:tailEnd type="triangle"/>
-          </a:ln>
-        </p:spPr>
-        <p:style>
-          <a:lnRef idx="2">
-            <a:schemeClr val="accent1"/>
-          </a:lnRef>
-          <a:fillRef idx="0">
-            <a:schemeClr val="accent1"/>
-          </a:fillRef>
-          <a:effectRef idx="1">
-            <a:schemeClr val="accent1"/>
-          </a:effectRef>
-          <a:fontRef idx="minor">
-            <a:schemeClr val="tx1"/>
-          </a:fontRef>
-        </p:style>
-      </p:cxnSp>
-      <p:cxnSp>
-        <p:nvCxnSpPr>
-          <p:cNvPr id="37" name="Connector 36"/>
+          <p:cNvPr id="39" name="Connector 38"/>
           <p:cNvCxnSpPr/>
           <p:nvPr/>
         </p:nvCxnSpPr>
@@ -8685,7 +8822,7 @@
       </p:cxnSp>
       <p:sp>
         <p:nvSpPr>
-          <p:cNvPr id="38" name="Rectangle 37"/>
+          <p:cNvPr id="40" name="Rectangle 39"/>
           <p:cNvSpPr/>
           <p:nvPr/>
         </p:nvSpPr>
@@ -8727,11 +8864,11 @@
           <a:p>
             <a:pPr algn="l">
               <a:spcAft>
-                <a:spcPts val="300"/>
+                <a:spcPts val="400"/>
               </a:spcAft>
             </a:pPr>
             <a:r>
-              <a:rPr sz="1050" b="1">
+              <a:rPr sz="1000" b="1">
                 <a:solidFill>
                   <a:srgbClr val="008CC8"/>
                 </a:solidFill>
@@ -8743,11 +8880,11 @@
           <a:p>
             <a:pPr algn="l">
               <a:spcAft>
-                <a:spcPts val="300"/>
+                <a:spcPts val="400"/>
               </a:spcAft>
             </a:pPr>
             <a:r>
-              <a:rPr sz="1050" b="1">
+              <a:rPr sz="1000" b="1">
                 <a:solidFill>
                   <a:srgbClr val="008CC8"/>
                 </a:solidFill>
@@ -8756,7 +8893,7 @@
               <a:t>▸ </a:t>
             </a:r>
             <a:r>
-              <a:rPr sz="1050" b="1">
+              <a:rPr sz="1000" b="1">
                 <a:solidFill>
                   <a:srgbClr val="0B2E4F"/>
                 </a:solidFill>
@@ -8765,23 +8902,23 @@
               <a:t>Tins: </a:t>
             </a:r>
             <a:r>
-              <a:rPr sz="1050" b="0">
+              <a:rPr sz="1000" b="0">
                 <a:solidFill>
                   <a:srgbClr val="333333"/>
                 </a:solidFill>
                 <a:latin typeface="Calibri"/>
               </a:rPr>
-              <a:t>call audio + gaming → Voice; call video → Video (RFC 8837 WebRTC marking); bulk → Bulk; Unknown never boosted</a:t>
+              <a:t>call audio + gaming → Voice; call video → Video (Voice tin is only 25%; RFC 8837); Unknown never boosted</a:t>
             </a:r>
           </a:p>
           <a:p>
             <a:pPr algn="l">
               <a:spcAft>
-                <a:spcPts val="300"/>
+                <a:spcPts val="400"/>
               </a:spcAft>
             </a:pPr>
             <a:r>
-              <a:rPr sz="1050" b="1">
+              <a:rPr sz="1000" b="1">
                 <a:solidFill>
                   <a:srgbClr val="008CC8"/>
                 </a:solidFill>
@@ -8790,7 +8927,7 @@
               <a:t>▸ </a:t>
             </a:r>
             <a:r>
-              <a:rPr sz="1050" b="1">
+              <a:rPr sz="1000" b="1">
                 <a:solidFill>
                   <a:srgbClr val="0B2E4F"/>
                 </a:solidFill>
@@ -8799,23 +8936,23 @@
               <a:t>Trust: </a:t>
             </a:r>
             <a:r>
-              <a:rPr sz="1050" b="0">
+              <a:rPr sz="1000" b="0">
                 <a:solidFill>
                   <a:srgbClr val="333333"/>
                 </a:solidFill>
                 <a:latin typeface="Calibri"/>
               </a:rPr>
-              <a:t>inbound DSCP from the Internet is ignored; download class is restored from our own conntrack mark</a:t>
+              <a:t>Internet DSCP is cleared on arrival; only our own conntrack mark sets priority</a:t>
             </a:r>
           </a:p>
           <a:p>
             <a:pPr algn="l">
               <a:spcAft>
-                <a:spcPts val="300"/>
+                <a:spcPts val="400"/>
               </a:spcAft>
             </a:pPr>
             <a:r>
-              <a:rPr sz="1050" b="1">
+              <a:rPr sz="1000" b="1">
                 <a:solidFill>
                   <a:srgbClr val="008CC8"/>
                 </a:solidFill>
@@ -8824,32 +8961,32 @@
               <a:t>▸ </a:t>
             </a:r>
             <a:r>
-              <a:rPr sz="1050" b="1">
+              <a:rPr sz="1000" b="1">
                 <a:solidFill>
                   <a:srgbClr val="0B2E4F"/>
                 </a:solidFill>
                 <a:latin typeface="Calibri"/>
               </a:rPr>
-              <a:t>Two speeds: </a:t>
-            </a:r>
-            <a:r>
-              <a:rPr sz="1050" b="0">
+              <a:t>Link realism: </a:t>
+            </a:r>
+            <a:r>
+              <a:rPr sz="1000" b="0">
                 <a:solidFill>
                   <a:srgbClr val="333333"/>
                 </a:solidFill>
                 <a:latin typeface="Calibri"/>
               </a:rPr>
-              <a:t>capacity cuts act within a second; policy changes wait for the safety gate, so a link drop is never blocked by anti-flap rules</a:t>
+              <a:t>overhead compensation, upload ACK filter, per-direction one-way delay</a:t>
             </a:r>
           </a:p>
           <a:p>
             <a:pPr algn="l">
               <a:spcAft>
-                <a:spcPts val="300"/>
+                <a:spcPts val="400"/>
               </a:spcAft>
             </a:pPr>
             <a:r>
-              <a:rPr sz="1050" b="1">
+              <a:rPr sz="1000" b="1">
                 <a:solidFill>
                   <a:srgbClr val="008CC8"/>
                 </a:solidFill>
@@ -8858,29 +8995,29 @@
               <a:t>▸ </a:t>
             </a:r>
             <a:r>
-              <a:rPr sz="1050" b="1">
+              <a:rPr sz="1000" b="1">
                 <a:solidFill>
                   <a:srgbClr val="0B2E4F"/>
                 </a:solidFill>
                 <a:latin typeface="Calibri"/>
               </a:rPr>
-              <a:t>Privacy: </a:t>
-            </a:r>
-            <a:r>
-              <a:rPr sz="1050" b="0">
+              <a:t>Privacy &amp; abuse: </a:t>
+            </a:r>
+            <a:r>
+              <a:rPr sz="1000" b="0">
                 <a:solidFill>
                   <a:srgbClr val="333333"/>
                 </a:solidFill>
                 <a:latin typeface="Calibri"/>
               </a:rPr>
-              <a:t>metadata only, no payload or domain logging; per-device views only to the account owner</a:t>
-            </a:r>
-          </a:p>
-        </p:txBody>
-      </p:sp>
-      <p:sp>
-        <p:nvSpPr>
-          <p:cNvPr id="39" name="Rectangle 38"/>
+              <a:t>no payload or domain logging; LAN-only authenticated intent API with budgets</a:t>
+            </a:r>
+          </a:p>
+        </p:txBody>
+      </p:sp>
+      <p:sp>
+        <p:nvSpPr>
+          <p:cNvPr id="41" name="Rectangle 40"/>
           <p:cNvSpPr/>
           <p:nvPr/>
         </p:nvSpPr>
@@ -8888,6 +9025,229 @@
           <a:xfrm>
             <a:off x="7360920" y="822960"/>
             <a:ext cx="4553712" cy="329184"/>
+          </a:xfrm>
+          <a:prstGeom prst="rect">
+            <a:avLst/>
+          </a:prstGeom>
+          <a:solidFill>
+            <a:srgbClr val="7A3FC9"/>
+          </a:solidFill>
+          <a:ln>
+            <a:noFill/>
+          </a:ln>
+          <a:effectLst/>
+        </p:spPr>
+        <p:style>
+          <a:lnRef idx="1">
+            <a:schemeClr val="accent1"/>
+          </a:lnRef>
+          <a:fillRef idx="3">
+            <a:schemeClr val="accent1"/>
+          </a:fillRef>
+          <a:effectRef idx="2">
+            <a:schemeClr val="accent1"/>
+          </a:effectRef>
+          <a:fontRef idx="minor">
+            <a:schemeClr val="lt1"/>
+          </a:fontRef>
+        </p:style>
+        <p:txBody>
+          <a:bodyPr rtlCol="0" anchor="ctr" wrap="square" lIns="54864" rIns="54864" tIns="27432" bIns="27432"/>
+          <a:lstStyle/>
+          <a:p>
+            <a:pPr algn="ctr"/>
+            <a:r>
+              <a:rPr sz="1050" b="1">
+                <a:solidFill>
+                  <a:srgbClr val="FFFFFF"/>
+                </a:solidFill>
+                <a:latin typeface="Calibri"/>
+              </a:rPr>
+              <a:t>THE AI ONLY PULSEQOS HAS — each must beat a rule-based twin</a:t>
+            </a:r>
+          </a:p>
+        </p:txBody>
+      </p:sp>
+      <p:sp>
+        <p:nvSpPr>
+          <p:cNvPr id="42" name="Rectangle 41"/>
+          <p:cNvSpPr/>
+          <p:nvPr/>
+        </p:nvSpPr>
+        <p:spPr>
+          <a:xfrm>
+            <a:off x="7360920" y="1152144"/>
+            <a:ext cx="4553712" cy="2670048"/>
+          </a:xfrm>
+          <a:prstGeom prst="rect">
+            <a:avLst/>
+          </a:prstGeom>
+          <a:solidFill>
+            <a:srgbClr val="FFFFFF"/>
+          </a:solidFill>
+          <a:ln w="12700">
+            <a:solidFill>
+              <a:srgbClr val="7A3FC9"/>
+            </a:solidFill>
+          </a:ln>
+          <a:effectLst/>
+        </p:spPr>
+        <p:style>
+          <a:lnRef idx="1">
+            <a:schemeClr val="accent1"/>
+          </a:lnRef>
+          <a:fillRef idx="3">
+            <a:schemeClr val="accent1"/>
+          </a:fillRef>
+          <a:effectRef idx="2">
+            <a:schemeClr val="accent1"/>
+          </a:effectRef>
+          <a:fontRef idx="minor">
+            <a:schemeClr val="lt1"/>
+          </a:fontRef>
+        </p:style>
+        <p:txBody>
+          <a:bodyPr rtlCol="0" anchor="t" wrap="square" lIns="54864" rIns="54864" tIns="27432" bIns="27432"/>
+          <a:lstStyle/>
+          <a:p>
+            <a:pPr algn="l">
+              <a:spcAft>
+                <a:spcPts val="400"/>
+              </a:spcAft>
+            </a:pPr>
+            <a:r>
+              <a:rPr sz="1050" b="1">
+                <a:solidFill>
+                  <a:srgbClr val="7A3FC9"/>
+                </a:solidFill>
+                <a:latin typeface="Calibri"/>
+              </a:rPr>
+              <a:t>1  Conformal classifier. </a:t>
+            </a:r>
+            <a:r>
+              <a:rPr sz="1050" b="0">
+                <a:solidFill>
+                  <a:srgbClr val="333333"/>
+                </a:solidFill>
+                <a:latin typeface="Calibri"/>
+              </a:rPr>
+              <a:t>Boosts a flow only when its prediction set is a single call/game class, so wrong boosts stay ≤ a chosen rate (e.g. 1%) by construction on calibration-like traffic. </a:t>
+            </a:r>
+            <a:r>
+              <a:rPr sz="1050" b="1">
+                <a:solidFill>
+                  <a:srgbClr val="0B2E4F"/>
+                </a:solidFill>
+                <a:latin typeface="Calibri"/>
+              </a:rPr>
+              <a:t>vs port rules</a:t>
+            </a:r>
+          </a:p>
+          <a:p>
+            <a:pPr algn="l">
+              <a:spcAft>
+                <a:spcPts val="400"/>
+              </a:spcAft>
+            </a:pPr>
+            <a:r>
+              <a:rPr sz="1050" b="1">
+                <a:solidFill>
+                  <a:srgbClr val="7A3FC9"/>
+                </a:solidFill>
+                <a:latin typeface="Calibri"/>
+              </a:rPr>
+              <a:t>2  Experience Twin. </a:t>
+            </a:r>
+            <a:r>
+              <a:rPr sz="1050" b="0">
+                <a:solidFill>
+                  <a:srgbClr val="333333"/>
+                </a:solidFill>
+                <a:latin typeface="Calibri"/>
+              </a:rPr>
+              <a:t>Learned model of the home link (trained offline in the lab, never by exploring on users) predicts each change’s effect and rejects harmful ones before they go live. </a:t>
+            </a:r>
+            <a:r>
+              <a:rPr sz="1050" b="1">
+                <a:solidFill>
+                  <a:srgbClr val="0B2E4F"/>
+                </a:solidFill>
+                <a:latin typeface="Calibri"/>
+              </a:rPr>
+              <a:t>metric: harm-seconds avoided</a:t>
+            </a:r>
+          </a:p>
+          <a:p>
+            <a:pPr algn="l">
+              <a:spcAft>
+                <a:spcPts val="400"/>
+              </a:spcAft>
+            </a:pPr>
+            <a:r>
+              <a:rPr sz="1050" b="1">
+                <a:solidFill>
+                  <a:srgbClr val="7A3FC9"/>
+                </a:solidFill>
+                <a:latin typeface="Calibri"/>
+              </a:rPr>
+              <a:t>3  Zero-click Focus. </a:t>
+            </a:r>
+            <a:r>
+              <a:rPr sz="1050" b="0">
+                <a:solidFill>
+                  <a:srgbClr val="333333"/>
+                </a:solidFill>
+                <a:latin typeface="Calibri"/>
+              </a:rPr>
+              <a:t>Detects a call starting on a busy link and protects it within seconds, charged to a Fairness Budget, with undo. </a:t>
+            </a:r>
+            <a:r>
+              <a:rPr sz="1050" b="1">
+                <a:solidFill>
+                  <a:srgbClr val="0B2E4F"/>
+                </a:solidFill>
+                <a:latin typeface="Calibri"/>
+              </a:rPr>
+              <a:t>metric: time-to-protection</a:t>
+            </a:r>
+          </a:p>
+          <a:p>
+            <a:pPr algn="l">
+              <a:spcAft>
+                <a:spcPts val="400"/>
+              </a:spcAft>
+            </a:pPr>
+            <a:r>
+              <a:rPr sz="1050" b="1">
+                <a:solidFill>
+                  <a:srgbClr val="0B2E4F"/>
+                </a:solidFill>
+                <a:latin typeface="Calibri"/>
+              </a:rPr>
+              <a:t>No chatbot: </a:t>
+            </a:r>
+            <a:r>
+              <a:rPr sz="1050" b="0">
+                <a:solidFill>
+                  <a:srgbClr val="333333"/>
+                </a:solidFill>
+                <a:latin typeface="Calibri"/>
+              </a:rPr>
+              <a:t>the case asks AI to improve a measurable outcome, not add a chat interface. An AI part that loses its A/B test is switched off.</a:t>
+            </a:r>
+          </a:p>
+        </p:txBody>
+      </p:sp>
+      <p:sp>
+        <p:nvSpPr>
+          <p:cNvPr id="43" name="Rectangle 42"/>
+          <p:cNvSpPr/>
+          <p:nvPr/>
+        </p:nvSpPr>
+        <p:spPr>
+          <a:xfrm>
+            <a:off x="7360920" y="3913632"/>
+            <a:ext cx="4553712" cy="292608"/>
           </a:xfrm>
           <a:prstGeom prst="rect">
             <a:avLst/>
@@ -8920,27 +9280,27 @@
           <a:p>
             <a:pPr algn="ctr"/>
             <a:r>
-              <a:rPr sz="1100" b="1">
+              <a:rPr sz="1050" b="1">
                 <a:solidFill>
                   <a:srgbClr val="F5B400"/>
                 </a:solidFill>
                 <a:latin typeface="Calibri"/>
               </a:rPr>
-              <a:t>PILOT EVIDENCE — measured, not assumed</a:t>
-            </a:r>
-          </a:p>
-        </p:txBody>
-      </p:sp>
-      <p:sp>
-        <p:nvSpPr>
-          <p:cNvPr id="40" name="Rectangle 39"/>
+              <a:t>PILOT EVIDENCE — measured 27 Oct, not assumed</a:t>
+            </a:r>
+          </a:p>
+        </p:txBody>
+      </p:sp>
+      <p:sp>
+        <p:nvSpPr>
+          <p:cNvPr id="44" name="Rectangle 43"/>
           <p:cNvSpPr/>
           <p:nvPr/>
         </p:nvSpPr>
         <p:spPr>
           <a:xfrm>
-            <a:off x="7360920" y="1152144"/>
-            <a:ext cx="4553712" cy="2395728"/>
+            <a:off x="7360920" y="4206240"/>
+            <a:ext cx="4553712" cy="2139696"/>
           </a:xfrm>
           <a:prstGeom prst="rect">
             <a:avLst/>
@@ -8979,15 +9339,15 @@
       </p:sp>
       <p:graphicFrame>
         <p:nvGraphicFramePr>
-          <p:cNvPr id="41" name="Chart 40"/>
+          <p:cNvPr id="45" name="Chart 44"/>
           <p:cNvGraphicFramePr>
             <a:graphicFrameLocks noGrp="1"/>
           </p:cNvGraphicFramePr>
           <p:nvPr/>
         </p:nvGraphicFramePr>
         <p:xfrm>
-          <a:off x="7406640" y="1188720"/>
-          <a:ext cx="4462272" cy="1325880"/>
+          <a:off x="7406640" y="4224528"/>
+          <a:ext cx="4462272" cy="1097280"/>
         </p:xfrm>
         <a:graphic>
           <a:graphicData uri="http://schemas.openxmlformats.org/drawingml/2006/chart">
@@ -8997,14 +9357,14 @@
       </p:graphicFrame>
       <p:sp>
         <p:nvSpPr>
-          <p:cNvPr id="42" name="TextBox 41"/>
+          <p:cNvPr id="46" name="TextBox 45"/>
           <p:cNvSpPr txBox="1"/>
           <p:nvPr/>
         </p:nvSpPr>
         <p:spPr>
           <a:xfrm>
-            <a:off x="7406640" y="2523744"/>
-            <a:ext cx="4462272" cy="1005840"/>
+            <a:off x="7406640" y="5303520"/>
+            <a:ext cx="4462272" cy="1024128"/>
           </a:xfrm>
           <a:prstGeom prst="rect">
             <a:avLst/>
@@ -9019,246 +9379,41 @@
           <a:p>
             <a:pPr algn="l"/>
             <a:r>
-              <a:rPr sz="950" b="1">
+              <a:rPr sz="900" b="1">
                 <a:solidFill>
                   <a:srgbClr val="0B2E4F"/>
                 </a:solidFill>
                 <a:latin typeface="Calibri"/>
               </a:rPr>
-              <a:t>Same download goodput in both: </a:t>
-            </a:r>
-            <a:r>
-              <a:rPr sz="950" b="0">
+              <a:t>Download goodput identical: </a:t>
+            </a:r>
+            <a:r>
+              <a:rPr sz="900" b="0">
                 <a:solidFill>
                   <a:srgbClr val="333333"/>
                 </a:solidFill>
                 <a:latin typeface="Calibri"/>
               </a:rPr>
-              <a:t>18.7 Mbps of 20 — the call is protected without starving bulk.</a:t>
+              <a:t>18.7 of 20 Mbps — call protected, bulk not starved.</a:t>
             </a:r>
           </a:p>
           <a:p>
             <a:pPr algn="l"/>
             <a:r>
-              <a:rPr sz="950" b="1">
-                <a:solidFill>
-                  <a:srgbClr val="0B2E4F"/>
+              <a:rPr sz="900" b="0">
+                <a:solidFill>
+                  <a:srgbClr val="333333"/>
                 </a:solidFill>
                 <a:latin typeface="Calibri"/>
               </a:rPr>
-              <a:t>Setup: </a:t>
-            </a:r>
-            <a:r>
-              <a:rPr sz="950" b="0">
-                <a:solidFill>
-                  <a:srgbClr val="333333"/>
-                </a:solidFill>
-                <a:latin typeface="Calibri"/>
-              </a:rPr>
-              <a:t>Linux namespaces, 20 Mbit bottleneck, 50 pkt/s probes, 5 paired runs (medians; FIFO range 128–152 ms). Emulation; no WAN delay or Wi-Fi; ideal classification. Round 2 repeats this with CAKE, netem and all baselines.</a:t>
-            </a:r>
-          </a:p>
-        </p:txBody>
-      </p:sp>
-      <p:sp>
-        <p:nvSpPr>
-          <p:cNvPr id="43" name="Rectangle 42"/>
-          <p:cNvSpPr/>
-          <p:nvPr/>
-        </p:nvSpPr>
-        <p:spPr>
-          <a:xfrm>
-            <a:off x="7360920" y="3657600"/>
-            <a:ext cx="4553712" cy="329184"/>
-          </a:xfrm>
-          <a:prstGeom prst="rect">
-            <a:avLst/>
-          </a:prstGeom>
-          <a:solidFill>
-            <a:srgbClr val="008CC8"/>
-          </a:solidFill>
-          <a:ln>
-            <a:noFill/>
-          </a:ln>
-          <a:effectLst/>
-        </p:spPr>
-        <p:style>
-          <a:lnRef idx="1">
-            <a:schemeClr val="accent1"/>
-          </a:lnRef>
-          <a:fillRef idx="3">
-            <a:schemeClr val="accent1"/>
-          </a:fillRef>
-          <a:effectRef idx="2">
-            <a:schemeClr val="accent1"/>
-          </a:effectRef>
-          <a:fontRef idx="minor">
-            <a:schemeClr val="lt1"/>
-          </a:fontRef>
-        </p:style>
-        <p:txBody>
-          <a:bodyPr rtlCol="0" anchor="ctr" wrap="square" lIns="54864" rIns="54864" tIns="27432" bIns="27432"/>
-          <a:lstStyle/>
-          <a:p>
-            <a:pPr algn="ctr"/>
-            <a:r>
-              <a:rPr sz="1100" b="1">
-                <a:solidFill>
-                  <a:srgbClr val="FFFFFF"/>
-                </a:solidFill>
-                <a:latin typeface="Calibri"/>
-              </a:rPr>
-              <a:t>UNDERSTAND → DECIDE → PROTECT → PROVE</a:t>
-            </a:r>
-          </a:p>
-        </p:txBody>
-      </p:sp>
-      <p:sp>
-        <p:nvSpPr>
-          <p:cNvPr id="44" name="Rectangle 43"/>
-          <p:cNvSpPr/>
-          <p:nvPr/>
-        </p:nvSpPr>
-        <p:spPr>
-          <a:xfrm>
-            <a:off x="7360920" y="3986784"/>
-            <a:ext cx="4553712" cy="2359152"/>
-          </a:xfrm>
-          <a:prstGeom prst="rect">
-            <a:avLst/>
-          </a:prstGeom>
-          <a:solidFill>
-            <a:srgbClr val="FFFFFF"/>
-          </a:solidFill>
-          <a:ln w="12700">
-            <a:solidFill>
-              <a:srgbClr val="008CC8"/>
-            </a:solidFill>
-          </a:ln>
-          <a:effectLst/>
-        </p:spPr>
-        <p:style>
-          <a:lnRef idx="1">
-            <a:schemeClr val="accent1"/>
-          </a:lnRef>
-          <a:fillRef idx="3">
-            <a:schemeClr val="accent1"/>
-          </a:fillRef>
-          <a:effectRef idx="2">
-            <a:schemeClr val="accent1"/>
-          </a:effectRef>
-          <a:fontRef idx="minor">
-            <a:schemeClr val="lt1"/>
-          </a:fontRef>
-        </p:style>
-        <p:txBody>
-          <a:bodyPr rtlCol="0" anchor="t" wrap="square" lIns="54864" rIns="54864" tIns="27432" bIns="27432"/>
-          <a:lstStyle/>
-          <a:p>
-            <a:pPr algn="l">
-              <a:spcAft>
-                <a:spcPts val="400"/>
-              </a:spcAft>
-            </a:pPr>
-            <a:r>
-              <a:rPr sz="1050" b="1">
-                <a:solidFill>
-                  <a:srgbClr val="0B2E4F"/>
-                </a:solidFill>
-                <a:latin typeface="Calibri"/>
-              </a:rPr>
-              <a:t>▸ Understand: </a:t>
-            </a:r>
-            <a:r>
-              <a:rPr sz="1050" b="0">
-                <a:solidFill>
-                  <a:srgbClr val="333333"/>
-                </a:solidFill>
-                <a:latin typeface="Calibri"/>
-              </a:rPr>
-              <a:t>LightGBM on flow metadata, trained on real app captures, split by session; reports confidence, abstains to Unknown; metrics: macro-F1, wrong-boost rate, time-to-classify.</a:t>
-            </a:r>
-          </a:p>
-          <a:p>
-            <a:pPr algn="l">
-              <a:spcAft>
-                <a:spcPts val="400"/>
-              </a:spcAft>
-            </a:pPr>
-            <a:r>
-              <a:rPr sz="1050" b="1">
-                <a:solidFill>
-                  <a:srgbClr val="0B2E4F"/>
-                </a:solidFill>
-                <a:latin typeface="Calibri"/>
-              </a:rPr>
-              <a:t>▸ Decide: </a:t>
-            </a:r>
-            <a:r>
-              <a:rPr sz="1050" b="0">
-                <a:solidFill>
-                  <a:srgbClr val="333333"/>
-                </a:solidFill>
-                <a:latin typeface="Calibri"/>
-              </a:rPr>
-              <a:t>Focus Mode with auto-expiry, priority ceiling and a daily Fairness Budget; a learned tuner stays only if it beats the rule controller in A/B runs.</a:t>
-            </a:r>
-          </a:p>
-          <a:p>
-            <a:pPr algn="l">
-              <a:spcAft>
-                <a:spcPts val="400"/>
-              </a:spcAft>
-            </a:pPr>
-            <a:r>
-              <a:rPr sz="1050" b="1">
-                <a:solidFill>
-                  <a:srgbClr val="0B2E4F"/>
-                </a:solidFill>
-                <a:latin typeface="Calibri"/>
-              </a:rPr>
-              <a:t>▸ Protect: </a:t>
-            </a:r>
-            <a:r>
-              <a:rPr sz="1050" b="0">
-                <a:solidFill>
-                  <a:srgbClr val="333333"/>
-                </a:solidFill>
-                <a:latin typeface="Calibri"/>
-              </a:rPr>
-              <a:t>fast-abort on call latency, whole-bundle rollback with read-back check, watchdog → known safe state.</a:t>
-            </a:r>
-          </a:p>
-          <a:p>
-            <a:pPr algn="l">
-              <a:spcAft>
-                <a:spcPts val="400"/>
-              </a:spcAft>
-            </a:pPr>
-            <a:r>
-              <a:rPr sz="1050" b="1">
-                <a:solidFill>
-                  <a:srgbClr val="0B2E4F"/>
-                </a:solidFill>
-                <a:latin typeface="Calibri"/>
-              </a:rPr>
-              <a:t>▸ Prove: </a:t>
-            </a:r>
-            <a:r>
-              <a:rPr sz="1050" b="0">
-                <a:solidFill>
-                  <a:srgbClr val="333333"/>
-                </a:solidFill>
-                <a:latin typeface="Calibri"/>
-              </a:rPr>
-              <a:t>one command runs 9 scenarios × 6 systems (FIFO, CAKE, CAKE+autorate, rule QoS, ours, ours+ML), 10 runs each: p95/p99 delay, jitter, loss, RPM, Jain, settle time, CPU.</a:t>
-            </a:r>
-          </a:p>
-        </p:txBody>
-      </p:sp>
-      <p:sp>
-        <p:nvSpPr>
-          <p:cNvPr id="45" name="TextBox 44"/>
+              <a:t>5 paired runs, Linux namespaces, 20 Mbit link; emulation without WAN delay, ideal classification. Round 2: CAKE, netem, 8 systems × 14 scenarios × 10 runs, incl. CAKE’s own autorate.</a:t>
+            </a:r>
+          </a:p>
+        </p:txBody>
+      </p:sp>
+      <p:sp>
+        <p:nvSpPr>
+          <p:cNvPr id="47" name="TextBox 46"/>
           <p:cNvSpPr txBox="1"/>
           <p:nvPr/>
         </p:nvSpPr>
@@ -9295,7 +9450,7 @@
                 </a:solidFill>
                 <a:latin typeface="Calibri"/>
               </a:rPr>
-              <a:t>reference implementation in emulation, labelled as such. A product also needs router hardware, flow-offload handling, gigabit CPU budget, Wi-Fi airtime fairness and a security review of the intent API.</a:t>
+              <a:t>reference implementation in emulation, labelled as such. A product also needs router hardware, flow-offload handling, gigabit CPU budget, Wi-Fi airtime fairness and certification.</a:t>
             </a:r>
           </a:p>
         </p:txBody>

</xml_diff>